<commit_message>
Update Python 4P part 4
</commit_message>
<xml_diff>
--- a/python_course_4p/4_api_app/4_api_app.pptx
+++ b/python_course_4p/4_api_app/4_api_app.pptx
@@ -5,7 +5,7 @@
     <p:sldMasterId id="2147483648" r:id="rId1"/>
   </p:sldMasterIdLst>
   <p:notesMasterIdLst>
-    <p:notesMasterId r:id="rId24"/>
+    <p:notesMasterId r:id="rId26"/>
   </p:notesMasterIdLst>
   <p:sldIdLst>
     <p:sldId id="322" r:id="rId2"/>
@@ -30,6 +30,8 @@
     <p:sldId id="356" r:id="rId21"/>
     <p:sldId id="357" r:id="rId22"/>
     <p:sldId id="358" r:id="rId23"/>
+    <p:sldId id="359" r:id="rId24"/>
+    <p:sldId id="360" r:id="rId25"/>
   </p:sldIdLst>
   <p:sldSz cx="12192000" cy="6858000"/>
   <p:notesSz cx="6858000" cy="9144000"/>
@@ -230,7 +232,7 @@
           <a:p>
             <a:fld id="{7D183437-14DE-4969-B062-63D9C4A2E219}" type="datetimeFigureOut">
               <a:rPr lang="nl-NL" smtClean="0"/>
-              <a:t>26-10-2026</a:t>
+              <a:t>28-10-2026</a:t>
             </a:fld>
             <a:endParaRPr lang="nl-NL"/>
           </a:p>
@@ -647,7 +649,7 @@
           <a:p>
             <a:fld id="{0EBB069A-003F-4FC0-8534-236B0C5C7B5F}" type="datetimeFigureOut">
               <a:rPr lang="en-NL" smtClean="0"/>
-              <a:t>26/10/2026</a:t>
+              <a:t>28/10/2026</a:t>
             </a:fld>
             <a:endParaRPr lang="en-NL"/>
           </a:p>
@@ -847,7 +849,7 @@
           <a:p>
             <a:fld id="{0EBB069A-003F-4FC0-8534-236B0C5C7B5F}" type="datetimeFigureOut">
               <a:rPr lang="en-NL" smtClean="0"/>
-              <a:t>26/10/2026</a:t>
+              <a:t>28/10/2026</a:t>
             </a:fld>
             <a:endParaRPr lang="en-NL"/>
           </a:p>
@@ -1057,7 +1059,7 @@
           <a:p>
             <a:fld id="{0EBB069A-003F-4FC0-8534-236B0C5C7B5F}" type="datetimeFigureOut">
               <a:rPr lang="en-NL" smtClean="0"/>
-              <a:t>26/10/2026</a:t>
+              <a:t>28/10/2026</a:t>
             </a:fld>
             <a:endParaRPr lang="en-NL"/>
           </a:p>
@@ -1257,7 +1259,7 @@
           <a:p>
             <a:fld id="{0EBB069A-003F-4FC0-8534-236B0C5C7B5F}" type="datetimeFigureOut">
               <a:rPr lang="en-NL" smtClean="0"/>
-              <a:t>26/10/2026</a:t>
+              <a:t>28/10/2026</a:t>
             </a:fld>
             <a:endParaRPr lang="en-NL"/>
           </a:p>
@@ -1533,7 +1535,7 @@
           <a:p>
             <a:fld id="{0EBB069A-003F-4FC0-8534-236B0C5C7B5F}" type="datetimeFigureOut">
               <a:rPr lang="en-NL" smtClean="0"/>
-              <a:t>26/10/2026</a:t>
+              <a:t>28/10/2026</a:t>
             </a:fld>
             <a:endParaRPr lang="en-NL"/>
           </a:p>
@@ -1801,7 +1803,7 @@
           <a:p>
             <a:fld id="{0EBB069A-003F-4FC0-8534-236B0C5C7B5F}" type="datetimeFigureOut">
               <a:rPr lang="en-NL" smtClean="0"/>
-              <a:t>26/10/2026</a:t>
+              <a:t>28/10/2026</a:t>
             </a:fld>
             <a:endParaRPr lang="en-NL"/>
           </a:p>
@@ -2216,7 +2218,7 @@
           <a:p>
             <a:fld id="{0EBB069A-003F-4FC0-8534-236B0C5C7B5F}" type="datetimeFigureOut">
               <a:rPr lang="en-NL" smtClean="0"/>
-              <a:t>26/10/2026</a:t>
+              <a:t>28/10/2026</a:t>
             </a:fld>
             <a:endParaRPr lang="en-NL"/>
           </a:p>
@@ -2358,7 +2360,7 @@
           <a:p>
             <a:fld id="{0EBB069A-003F-4FC0-8534-236B0C5C7B5F}" type="datetimeFigureOut">
               <a:rPr lang="en-NL" smtClean="0"/>
-              <a:t>26/10/2026</a:t>
+              <a:t>28/10/2026</a:t>
             </a:fld>
             <a:endParaRPr lang="en-NL"/>
           </a:p>
@@ -2471,7 +2473,7 @@
           <a:p>
             <a:fld id="{0EBB069A-003F-4FC0-8534-236B0C5C7B5F}" type="datetimeFigureOut">
               <a:rPr lang="en-NL" smtClean="0"/>
-              <a:t>26/10/2026</a:t>
+              <a:t>28/10/2026</a:t>
             </a:fld>
             <a:endParaRPr lang="en-NL"/>
           </a:p>
@@ -2784,7 +2786,7 @@
           <a:p>
             <a:fld id="{0EBB069A-003F-4FC0-8534-236B0C5C7B5F}" type="datetimeFigureOut">
               <a:rPr lang="en-NL" smtClean="0"/>
-              <a:t>26/10/2026</a:t>
+              <a:t>28/10/2026</a:t>
             </a:fld>
             <a:endParaRPr lang="en-NL"/>
           </a:p>
@@ -3073,7 +3075,7 @@
           <a:p>
             <a:fld id="{0EBB069A-003F-4FC0-8534-236B0C5C7B5F}" type="datetimeFigureOut">
               <a:rPr lang="en-NL" smtClean="0"/>
-              <a:t>26/10/2026</a:t>
+              <a:t>28/10/2026</a:t>
             </a:fld>
             <a:endParaRPr lang="en-NL"/>
           </a:p>
@@ -3316,7 +3318,7 @@
           <a:p>
             <a:fld id="{0EBB069A-003F-4FC0-8534-236B0C5C7B5F}" type="datetimeFigureOut">
               <a:rPr lang="en-NL" smtClean="0"/>
-              <a:t>26/10/2026</a:t>
+              <a:t>28/10/2026</a:t>
             </a:fld>
             <a:endParaRPr lang="en-NL"/>
           </a:p>
@@ -9170,7 +9172,7 @@
             <a:pPr lvl="1"/>
             <a:r>
               <a:rPr lang="nl-NL" sz="1800" dirty="0"/>
-              <a:t>Een verplichte omschrijving.</a:t>
+              <a:t>Een verplichte omschrijving tussen de 3 en 250 karakters.</a:t>
             </a:r>
           </a:p>
           <a:p>
@@ -10127,7 +10129,7 @@
                   <a:latin typeface="Courier New" panose="02070309020205020404" pitchFamily="49" charset="0"/>
                   <a:cs typeface="Courier New" panose="02070309020205020404" pitchFamily="49" charset="0"/>
                 </a:rPr>
-                <a:t>POST /add + description</a:t>
+                <a:t>GET /add + description</a:t>
               </a:r>
             </a:p>
           </p:txBody>
@@ -10228,7 +10230,7 @@
                   <a:latin typeface="Courier New" panose="02070309020205020404" pitchFamily="49" charset="0"/>
                   <a:cs typeface="Courier New" panose="02070309020205020404" pitchFamily="49" charset="0"/>
                 </a:rPr>
-                <a:t>POST /update + id + status</a:t>
+                <a:t>GET /update + id + status</a:t>
               </a:r>
             </a:p>
           </p:txBody>
@@ -10329,7 +10331,7 @@
                   <a:latin typeface="Courier New" panose="02070309020205020404" pitchFamily="49" charset="0"/>
                   <a:cs typeface="Courier New" panose="02070309020205020404" pitchFamily="49" charset="0"/>
                 </a:rPr>
-                <a:t>POST /delete + id</a:t>
+                <a:t>GET /delete + id</a:t>
               </a:r>
             </a:p>
           </p:txBody>
@@ -12278,7 +12280,7 @@
                 <a:latin typeface="Courier New" panose="02070309020205020404" pitchFamily="49" charset="0"/>
                 <a:cs typeface="Courier New" panose="02070309020205020404" pitchFamily="49" charset="0"/>
               </a:rPr>
-              <a:t># Maak API aan.</a:t>
+              <a:t># Maak API app aan.</a:t>
             </a:r>
           </a:p>
           <a:p>
@@ -12295,18 +12297,11 @@
               <a:buNone/>
             </a:pPr>
             <a:r>
-              <a:rPr lang="nl-NL" sz="1400" dirty="0" err="1">
-                <a:latin typeface="Courier New" panose="02070309020205020404" pitchFamily="49" charset="0"/>
-                <a:cs typeface="Courier New" panose="02070309020205020404" pitchFamily="49" charset="0"/>
-              </a:rPr>
-              <a:t>api</a:t>
-            </a:r>
-            <a:r>
               <a:rPr lang="nl-NL" sz="1400" dirty="0">
                 <a:latin typeface="Courier New" panose="02070309020205020404" pitchFamily="49" charset="0"/>
                 <a:cs typeface="Courier New" panose="02070309020205020404" pitchFamily="49" charset="0"/>
               </a:rPr>
-              <a:t> = </a:t>
+              <a:t>app = </a:t>
             </a:r>
             <a:r>
               <a:rPr lang="nl-NL" sz="1400" dirty="0" err="1">
@@ -12770,7 +12765,7 @@
               <a:buNone/>
             </a:pPr>
             <a:r>
-              <a:rPr lang="nl-NL" sz="1800" dirty="0"/>
+              <a:rPr lang="nl-NL" sz="1600" dirty="0"/>
               <a:t>Drie manieren om data mee te geven:</a:t>
             </a:r>
           </a:p>
@@ -12781,17 +12776,17 @@
               </a:spcAft>
               <a:buNone/>
             </a:pPr>
-            <a:endParaRPr lang="nl-NL" sz="1800" dirty="0"/>
-          </a:p>
-          <a:p>
-            <a:pPr marL="0" indent="0">
-              <a:spcAft>
-                <a:spcPts val="600"/>
-              </a:spcAft>
-              <a:buNone/>
-            </a:pPr>
-            <a:r>
-              <a:rPr lang="nl-NL" sz="1800" b="1" dirty="0"/>
+            <a:endParaRPr lang="nl-NL" sz="1600" dirty="0"/>
+          </a:p>
+          <a:p>
+            <a:pPr marL="0" indent="0">
+              <a:spcAft>
+                <a:spcPts val="600"/>
+              </a:spcAft>
+              <a:buNone/>
+            </a:pPr>
+            <a:r>
+              <a:rPr lang="nl-NL" sz="1600" b="1" dirty="0"/>
               <a:t>In het pad</a:t>
             </a:r>
           </a:p>
@@ -12803,38 +12798,38 @@
               <a:buNone/>
             </a:pPr>
             <a:r>
-              <a:rPr lang="nl-NL" sz="1800" dirty="0"/>
+              <a:rPr lang="nl-NL" sz="1600" dirty="0"/>
               <a:t>http://localhost:8080/greet/</a:t>
             </a:r>
             <a:r>
-              <a:rPr lang="nl-NL" sz="1800" b="1" dirty="0">
+              <a:rPr lang="nl-NL" sz="1600" b="1" dirty="0">
                 <a:solidFill>
                   <a:schemeClr val="accent5">
                     <a:lumMod val="75000"/>
                   </a:schemeClr>
                 </a:solidFill>
               </a:rPr>
-              <a:t>John</a:t>
-            </a:r>
-          </a:p>
-          <a:p>
-            <a:pPr marL="0" indent="0">
-              <a:spcAft>
-                <a:spcPts val="600"/>
-              </a:spcAft>
-              <a:buNone/>
-            </a:pPr>
-            <a:endParaRPr lang="nl-NL" sz="1800" dirty="0"/>
-          </a:p>
-          <a:p>
-            <a:pPr marL="0" indent="0">
-              <a:spcAft>
-                <a:spcPts val="600"/>
-              </a:spcAft>
-              <a:buNone/>
-            </a:pPr>
-            <a:r>
-              <a:rPr lang="nl-NL" sz="1800" b="1" dirty="0"/>
+              <a:t>John/Doe</a:t>
+            </a:r>
+          </a:p>
+          <a:p>
+            <a:pPr marL="0" indent="0">
+              <a:spcAft>
+                <a:spcPts val="600"/>
+              </a:spcAft>
+              <a:buNone/>
+            </a:pPr>
+            <a:endParaRPr lang="nl-NL" sz="1600" dirty="0"/>
+          </a:p>
+          <a:p>
+            <a:pPr marL="0" indent="0">
+              <a:spcAft>
+                <a:spcPts val="600"/>
+              </a:spcAft>
+              <a:buNone/>
+            </a:pPr>
+            <a:r>
+              <a:rPr lang="nl-NL" sz="1600" b="1" dirty="0"/>
               <a:t>Als query</a:t>
             </a:r>
           </a:p>
@@ -12846,38 +12841,38 @@
               <a:buNone/>
             </a:pPr>
             <a:r>
-              <a:rPr lang="nl-NL" sz="1800" dirty="0"/>
+              <a:rPr lang="nl-NL" sz="1600" dirty="0"/>
               <a:t>http://localhost:8080/add</a:t>
             </a:r>
             <a:r>
-              <a:rPr lang="nl-NL" sz="1800" b="1" dirty="0">
+              <a:rPr lang="nl-NL" sz="1600" b="1" dirty="0">
                 <a:solidFill>
                   <a:schemeClr val="accent5">
                     <a:lumMod val="75000"/>
                   </a:schemeClr>
                 </a:solidFill>
               </a:rPr>
-              <a:t>?name=John</a:t>
-            </a:r>
-          </a:p>
-          <a:p>
-            <a:pPr marL="0" indent="0">
-              <a:spcAft>
-                <a:spcPts val="600"/>
-              </a:spcAft>
-              <a:buNone/>
-            </a:pPr>
-            <a:endParaRPr lang="nl-NL" sz="1800" b="1" dirty="0"/>
-          </a:p>
-          <a:p>
-            <a:pPr marL="0" indent="0">
-              <a:spcAft>
-                <a:spcPts val="600"/>
-              </a:spcAft>
-              <a:buNone/>
-            </a:pPr>
-            <a:r>
-              <a:rPr lang="nl-NL" sz="1800" b="1" dirty="0"/>
+              <a:t>?name=John&amp;last_name=Doe</a:t>
+            </a:r>
+          </a:p>
+          <a:p>
+            <a:pPr marL="0" indent="0">
+              <a:spcAft>
+                <a:spcPts val="600"/>
+              </a:spcAft>
+              <a:buNone/>
+            </a:pPr>
+            <a:endParaRPr lang="nl-NL" sz="1600" b="1" dirty="0"/>
+          </a:p>
+          <a:p>
+            <a:pPr marL="0" indent="0">
+              <a:spcAft>
+                <a:spcPts val="600"/>
+              </a:spcAft>
+              <a:buNone/>
+            </a:pPr>
+            <a:r>
+              <a:rPr lang="nl-NL" sz="1600" b="1" dirty="0"/>
               <a:t>Als body</a:t>
             </a:r>
           </a:p>
@@ -12889,7 +12884,7 @@
               <a:buNone/>
             </a:pPr>
             <a:r>
-              <a:rPr lang="nl-NL" sz="1800" dirty="0">
+              <a:rPr lang="nl-NL" sz="1600" dirty="0">
                 <a:solidFill>
                   <a:schemeClr val="accent5">
                     <a:lumMod val="75000"/>
@@ -12899,7 +12894,7 @@
               <a:t>{"name": "John", "</a:t>
             </a:r>
             <a:r>
-              <a:rPr lang="nl-NL" sz="1800" dirty="0" err="1">
+              <a:rPr lang="nl-NL" sz="1600" dirty="0" err="1">
                 <a:solidFill>
                   <a:schemeClr val="accent5">
                     <a:lumMod val="75000"/>
@@ -12909,7 +12904,7 @@
               <a:t>last_name</a:t>
             </a:r>
             <a:r>
-              <a:rPr lang="nl-NL" sz="1800" dirty="0">
+              <a:rPr lang="nl-NL" sz="1600" dirty="0">
                 <a:solidFill>
                   <a:schemeClr val="accent5">
                     <a:lumMod val="75000"/>
@@ -13206,6 +13201,30 @@
                 <a:latin typeface="Courier New" panose="02070309020205020404" pitchFamily="49" charset="0"/>
                 <a:cs typeface="Courier New" panose="02070309020205020404" pitchFamily="49" charset="0"/>
               </a:rPr>
+              <a:t>/</a:t>
+            </a:r>
+            <a:r>
+              <a:rPr lang="en-US" sz="1400" dirty="0">
+                <a:solidFill>
+                  <a:schemeClr val="accent5">
+                    <a:lumMod val="75000"/>
+                  </a:schemeClr>
+                </a:solidFill>
+                <a:latin typeface="Courier New" panose="02070309020205020404" pitchFamily="49" charset="0"/>
+                <a:cs typeface="Courier New" panose="02070309020205020404" pitchFamily="49" charset="0"/>
+              </a:rPr>
+              <a:t>{last_name}</a:t>
+            </a:r>
+            <a:r>
+              <a:rPr lang="en-US" sz="1400" dirty="0">
+                <a:solidFill>
+                  <a:schemeClr val="accent2">
+                    <a:lumMod val="75000"/>
+                  </a:schemeClr>
+                </a:solidFill>
+                <a:latin typeface="Courier New" panose="02070309020205020404" pitchFamily="49" charset="0"/>
+                <a:cs typeface="Courier New" panose="02070309020205020404" pitchFamily="49" charset="0"/>
+              </a:rPr>
               <a:t>"</a:t>
             </a:r>
             <a:r>
@@ -13412,7 +13431,21 @@
                 <a:latin typeface="Courier New" panose="02070309020205020404" pitchFamily="49" charset="0"/>
                 <a:cs typeface="Courier New" panose="02070309020205020404" pitchFamily="49" charset="0"/>
               </a:rPr>
-              <a:t>greet(name: str):</a:t>
+              <a:t>greet(name: str, </a:t>
+            </a:r>
+            <a:r>
+              <a:rPr lang="en-US" sz="1400" dirty="0" err="1">
+                <a:latin typeface="Courier New" panose="02070309020205020404" pitchFamily="49" charset="0"/>
+                <a:cs typeface="Courier New" panose="02070309020205020404" pitchFamily="49" charset="0"/>
+              </a:rPr>
+              <a:t>last_name</a:t>
+            </a:r>
+            <a:r>
+              <a:rPr lang="en-US" sz="1400" dirty="0">
+                <a:latin typeface="Courier New" panose="02070309020205020404" pitchFamily="49" charset="0"/>
+                <a:cs typeface="Courier New" panose="02070309020205020404" pitchFamily="49" charset="0"/>
+              </a:rPr>
+              <a:t>: str):</a:t>
             </a:r>
           </a:p>
           <a:p>
@@ -13681,6 +13714,50 @@
           </a:fontRef>
         </p:style>
       </p:cxnSp>
+      <p:sp>
+        <p:nvSpPr>
+          <p:cNvPr id="5" name="TextBox 4">
+            <a:extLst>
+              <a:ext uri="{FF2B5EF4-FFF2-40B4-BE49-F238E27FC236}">
+                <a16:creationId xmlns:a16="http://schemas.microsoft.com/office/drawing/2014/main" id="{0833D66C-9D05-F3F9-7F86-0744E090D6D0}"/>
+              </a:ext>
+            </a:extLst>
+          </p:cNvPr>
+          <p:cNvSpPr txBox="1"/>
+          <p:nvPr/>
+        </p:nvSpPr>
+        <p:spPr>
+          <a:xfrm>
+            <a:off x="9619967" y="6471982"/>
+            <a:ext cx="2499246" cy="307777"/>
+          </a:xfrm>
+          <a:prstGeom prst="rect">
+            <a:avLst/>
+          </a:prstGeom>
+          <a:noFill/>
+        </p:spPr>
+        <p:txBody>
+          <a:bodyPr wrap="square">
+            <a:spAutoFit/>
+          </a:bodyPr>
+          <a:lstStyle/>
+          <a:p>
+            <a:pPr algn="r"/>
+            <a:r>
+              <a:rPr lang="en-US" sz="1400" dirty="0"/>
+              <a:t>D: params </a:t>
+            </a:r>
+            <a:r>
+              <a:rPr lang="en-US" sz="1400" dirty="0" err="1"/>
+              <a:t>api</a:t>
+            </a:r>
+            <a:r>
+              <a:rPr lang="en-US" sz="1400" dirty="0"/>
+              <a:t>.</a:t>
+            </a:r>
+          </a:p>
+        </p:txBody>
+      </p:sp>
     </p:spTree>
     <p:extLst>
       <p:ext uri="{BB962C8B-B14F-4D97-AF65-F5344CB8AC3E}">
@@ -13780,13 +13857,12 @@
           </a:bodyPr>
           <a:lstStyle/>
           <a:p>
-            <a:pPr marL="457200" indent="-457200">
-              <a:buFont typeface="Arial" panose="020B0604020202020204" pitchFamily="34" charset="0"/>
-              <a:buAutoNum type="arabicPeriod"/>
+            <a:pPr marL="0" indent="0">
+              <a:buNone/>
             </a:pPr>
             <a:r>
               <a:rPr lang="nl-NL" sz="1800" dirty="0"/>
-              <a:t>Maak het end point om nieuwe </a:t>
+              <a:t>Maak het end point om een nieuw </a:t>
             </a:r>
             <a:r>
               <a:rPr lang="nl-NL" sz="1800" dirty="0" err="1"/>
@@ -13794,24 +13870,119 @@
             </a:r>
             <a:r>
               <a:rPr lang="nl-NL" sz="1800" dirty="0"/>
-              <a:t> Do items aan te maken:</a:t>
-            </a:r>
-          </a:p>
-          <a:p>
-            <a:pPr marL="457200" indent="-457200">
-              <a:buFont typeface="Arial" panose="020B0604020202020204" pitchFamily="34" charset="0"/>
-              <a:buAutoNum type="arabicPeriod"/>
+              <a:t> Do items te maken:</a:t>
+            </a:r>
+          </a:p>
+          <a:p>
+            <a:pPr marL="0" indent="0">
+              <a:buNone/>
             </a:pPr>
             <a:endParaRPr lang="nl-NL" sz="1800" dirty="0"/>
           </a:p>
           <a:p>
-            <a:pPr marL="914400" lvl="1" indent="-457200">
-              <a:buFont typeface="Arial" panose="020B0604020202020204" pitchFamily="34" charset="0"/>
-              <a:buAutoNum type="arabicPeriod"/>
-            </a:pPr>
             <a:r>
               <a:rPr lang="nl-NL" sz="1800" dirty="0"/>
-              <a:t>Blaat</a:t>
+              <a:t>Open </a:t>
+            </a:r>
+            <a:r>
+              <a:rPr lang="nl-NL" sz="1800" dirty="0" err="1">
+                <a:latin typeface="Courier New" panose="02070309020205020404" pitchFamily="49" charset="0"/>
+                <a:cs typeface="Courier New" panose="02070309020205020404" pitchFamily="49" charset="0"/>
+              </a:rPr>
+              <a:t>exercises</a:t>
+            </a:r>
+            <a:r>
+              <a:rPr lang="nl-NL" sz="1800" dirty="0">
+                <a:latin typeface="Courier New" panose="02070309020205020404" pitchFamily="49" charset="0"/>
+                <a:cs typeface="Courier New" panose="02070309020205020404" pitchFamily="49" charset="0"/>
+              </a:rPr>
+              <a:t>/1_api_create_endpoint.py</a:t>
+            </a:r>
+            <a:r>
+              <a:rPr lang="nl-NL" sz="1800" dirty="0"/>
+              <a:t>.</a:t>
+            </a:r>
+          </a:p>
+          <a:p>
+            <a:endParaRPr lang="nl-NL" sz="1800" dirty="0"/>
+          </a:p>
+          <a:p>
+            <a:r>
+              <a:rPr lang="nl-NL" sz="1800" dirty="0"/>
+              <a:t>Haal de beschrijving uit de </a:t>
+            </a:r>
+            <a:r>
+              <a:rPr lang="nl-NL" sz="1800" dirty="0" err="1">
+                <a:latin typeface="Courier New" panose="02070309020205020404" pitchFamily="49" charset="0"/>
+                <a:cs typeface="Courier New" panose="02070309020205020404" pitchFamily="49" charset="0"/>
+              </a:rPr>
+              <a:t>description</a:t>
+            </a:r>
+            <a:r>
+              <a:rPr lang="nl-NL" sz="1800" dirty="0"/>
+              <a:t> parameter van een GET </a:t>
+            </a:r>
+            <a:r>
+              <a:rPr lang="nl-NL" sz="1800" dirty="0" err="1"/>
+              <a:t>request</a:t>
+            </a:r>
+            <a:r>
+              <a:rPr lang="nl-NL" sz="1800" dirty="0"/>
+              <a:t>.</a:t>
+            </a:r>
+          </a:p>
+          <a:p>
+            <a:endParaRPr lang="nl-NL" sz="1800" dirty="0"/>
+          </a:p>
+          <a:p>
+            <a:r>
+              <a:rPr lang="nl-NL" sz="1800" dirty="0"/>
+              <a:t>Maak een </a:t>
+            </a:r>
+            <a:r>
+              <a:rPr lang="nl-NL" sz="1800" dirty="0" err="1">
+                <a:latin typeface="Courier New" panose="02070309020205020404" pitchFamily="49" charset="0"/>
+                <a:cs typeface="Courier New" panose="02070309020205020404" pitchFamily="49" charset="0"/>
+              </a:rPr>
+              <a:t>ToDoItem</a:t>
+            </a:r>
+            <a:r>
+              <a:rPr lang="nl-NL" sz="1800" dirty="0"/>
+              <a:t> aan met het </a:t>
+            </a:r>
+            <a:r>
+              <a:rPr lang="nl-NL" sz="1800" dirty="0" err="1"/>
+              <a:t>pydantic</a:t>
+            </a:r>
+            <a:r>
+              <a:rPr lang="nl-NL" sz="1800" dirty="0"/>
+              <a:t> model van de vorige opdracht.</a:t>
+            </a:r>
+          </a:p>
+          <a:p>
+            <a:endParaRPr lang="nl-NL" sz="1800" dirty="0"/>
+          </a:p>
+          <a:p>
+            <a:r>
+              <a:rPr lang="nl-NL" sz="1800" dirty="0"/>
+              <a:t>Schrijf het item naar een JSON-bestand in een </a:t>
+            </a:r>
+            <a:r>
+              <a:rPr lang="nl-NL" sz="1800" dirty="0" err="1"/>
+              <a:t>todo</a:t>
+            </a:r>
+            <a:r>
+              <a:rPr lang="nl-NL" sz="1800" dirty="0"/>
+              <a:t>-folder.</a:t>
+            </a:r>
+          </a:p>
+          <a:p>
+            <a:endParaRPr lang="nl-NL" sz="1800" dirty="0"/>
+          </a:p>
+          <a:p>
+            <a:r>
+              <a:rPr lang="nl-NL" sz="1800" dirty="0"/>
+              <a:t>Gebruik  het ID van het item als bestandsnaam</a:t>
             </a:r>
           </a:p>
           <a:p>
@@ -13826,6 +13997,1183 @@
     <p:extLst>
       <p:ext uri="{BB962C8B-B14F-4D97-AF65-F5344CB8AC3E}">
         <p14:creationId xmlns:p14="http://schemas.microsoft.com/office/powerpoint/2010/main" val="3696776232"/>
+      </p:ext>
+    </p:extLst>
+  </p:cSld>
+  <p:clrMapOvr>
+    <a:masterClrMapping/>
+  </p:clrMapOvr>
+</p:sld>
+</file>
+
+<file path=ppt/slides/slide23.xml><?xml version="1.0" encoding="utf-8"?>
+<p:sld xmlns:a="http://schemas.openxmlformats.org/drawingml/2006/main" xmlns:r="http://schemas.openxmlformats.org/officeDocument/2006/relationships" xmlns:p="http://schemas.openxmlformats.org/presentationml/2006/main">
+  <p:cSld>
+    <p:spTree>
+      <p:nvGrpSpPr>
+        <p:cNvPr id="1" name="">
+          <a:extLst>
+            <a:ext uri="{FF2B5EF4-FFF2-40B4-BE49-F238E27FC236}">
+              <a16:creationId xmlns:a16="http://schemas.microsoft.com/office/drawing/2014/main" id="{D4C6DEBF-0F09-811E-384B-EA6E0313D2A5}"/>
+            </a:ext>
+          </a:extLst>
+        </p:cNvPr>
+        <p:cNvGrpSpPr/>
+        <p:nvPr/>
+      </p:nvGrpSpPr>
+      <p:grpSpPr>
+        <a:xfrm>
+          <a:off x="0" y="0"/>
+          <a:ext cx="0" cy="0"/>
+          <a:chOff x="0" y="0"/>
+          <a:chExt cx="0" cy="0"/>
+        </a:xfrm>
+      </p:grpSpPr>
+      <p:sp>
+        <p:nvSpPr>
+          <p:cNvPr id="2" name="Title 1">
+            <a:extLst>
+              <a:ext uri="{FF2B5EF4-FFF2-40B4-BE49-F238E27FC236}">
+                <a16:creationId xmlns:a16="http://schemas.microsoft.com/office/drawing/2014/main" id="{79B436D9-2C79-CA55-6142-247664AC97DA}"/>
+              </a:ext>
+            </a:extLst>
+          </p:cNvPr>
+          <p:cNvSpPr>
+            <a:spLocks noGrp="1"/>
+          </p:cNvSpPr>
+          <p:nvPr>
+            <p:ph type="title"/>
+          </p:nvPr>
+        </p:nvSpPr>
+        <p:spPr>
+          <a:xfrm>
+            <a:off x="838200" y="365126"/>
+            <a:ext cx="10515600" cy="718608"/>
+          </a:xfrm>
+        </p:spPr>
+        <p:txBody>
+          <a:bodyPr>
+            <a:normAutofit/>
+          </a:bodyPr>
+          <a:lstStyle/>
+          <a:p>
+            <a:r>
+              <a:rPr lang="nl-NL" sz="3600" noProof="0" dirty="0"/>
+              <a:t>Oefeningen 2</a:t>
+            </a:r>
+          </a:p>
+        </p:txBody>
+      </p:sp>
+      <p:sp>
+        <p:nvSpPr>
+          <p:cNvPr id="3" name="Content Placeholder 2">
+            <a:extLst>
+              <a:ext uri="{FF2B5EF4-FFF2-40B4-BE49-F238E27FC236}">
+                <a16:creationId xmlns:a16="http://schemas.microsoft.com/office/drawing/2014/main" id="{F37DF745-2478-BB30-FBE4-CE7ED21C2D95}"/>
+              </a:ext>
+            </a:extLst>
+          </p:cNvPr>
+          <p:cNvSpPr>
+            <a:spLocks noGrp="1"/>
+          </p:cNvSpPr>
+          <p:nvPr>
+            <p:ph idx="1"/>
+          </p:nvPr>
+        </p:nvSpPr>
+        <p:spPr>
+          <a:xfrm>
+            <a:off x="838200" y="1456267"/>
+            <a:ext cx="10375900" cy="4720696"/>
+          </a:xfrm>
+        </p:spPr>
+        <p:txBody>
+          <a:bodyPr>
+            <a:noAutofit/>
+          </a:bodyPr>
+          <a:lstStyle/>
+          <a:p>
+            <a:pPr marL="0" indent="0">
+              <a:buNone/>
+            </a:pPr>
+            <a:r>
+              <a:rPr lang="nl-NL" sz="1800" dirty="0"/>
+              <a:t>Om je API op te starten gebruik:</a:t>
+            </a:r>
+          </a:p>
+          <a:p>
+            <a:pPr marL="0" indent="0">
+              <a:buNone/>
+            </a:pPr>
+            <a:endParaRPr lang="nl-NL" sz="1800" dirty="0"/>
+          </a:p>
+          <a:p>
+            <a:pPr marL="0" indent="0">
+              <a:buNone/>
+            </a:pPr>
+            <a:r>
+              <a:rPr lang="nl-NL" sz="1800" dirty="0" err="1">
+                <a:latin typeface="Courier New" panose="02070309020205020404" pitchFamily="49" charset="0"/>
+                <a:cs typeface="Courier New" panose="02070309020205020404" pitchFamily="49" charset="0"/>
+              </a:rPr>
+              <a:t>uvx</a:t>
+            </a:r>
+            <a:r>
+              <a:rPr lang="nl-NL" sz="1800" dirty="0">
+                <a:latin typeface="Courier New" panose="02070309020205020404" pitchFamily="49" charset="0"/>
+                <a:cs typeface="Courier New" panose="02070309020205020404" pitchFamily="49" charset="0"/>
+              </a:rPr>
+              <a:t> </a:t>
+            </a:r>
+            <a:r>
+              <a:rPr lang="nl-NL" sz="1800" dirty="0" err="1">
+                <a:latin typeface="Courier New" panose="02070309020205020404" pitchFamily="49" charset="0"/>
+                <a:cs typeface="Courier New" panose="02070309020205020404" pitchFamily="49" charset="0"/>
+              </a:rPr>
+              <a:t>fastapi</a:t>
+            </a:r>
+            <a:r>
+              <a:rPr lang="nl-NL" sz="1800" dirty="0">
+                <a:latin typeface="Courier New" panose="02070309020205020404" pitchFamily="49" charset="0"/>
+                <a:cs typeface="Courier New" panose="02070309020205020404" pitchFamily="49" charset="0"/>
+              </a:rPr>
+              <a:t>[standaard] run .\api_create.py</a:t>
+            </a:r>
+          </a:p>
+          <a:p>
+            <a:pPr marL="0" indent="0">
+              <a:buNone/>
+            </a:pPr>
+            <a:endParaRPr lang="nl-NL" sz="1800" dirty="0"/>
+          </a:p>
+          <a:p>
+            <a:pPr marL="0" indent="0">
+              <a:buNone/>
+            </a:pPr>
+            <a:r>
+              <a:rPr lang="nl-NL" sz="1800" dirty="0"/>
+              <a:t>Stoppen met CTRL + C</a:t>
+            </a:r>
+          </a:p>
+          <a:p>
+            <a:pPr marL="0" indent="0">
+              <a:buNone/>
+            </a:pPr>
+            <a:endParaRPr lang="nl-NL" sz="1800" dirty="0"/>
+          </a:p>
+          <a:p>
+            <a:pPr marL="0" indent="0">
+              <a:buNone/>
+            </a:pPr>
+            <a:endParaRPr lang="nl-NL" sz="1800" dirty="0"/>
+          </a:p>
+          <a:p>
+            <a:pPr marL="0" indent="0">
+              <a:buNone/>
+            </a:pPr>
+            <a:r>
+              <a:rPr lang="nl-NL" sz="1800" dirty="0"/>
+              <a:t>Om een item in te voeren, open een browser en ga naar:</a:t>
+            </a:r>
+          </a:p>
+          <a:p>
+            <a:pPr marL="0" indent="0">
+              <a:buNone/>
+            </a:pPr>
+            <a:endParaRPr lang="nl-NL" sz="1800" dirty="0"/>
+          </a:p>
+          <a:p>
+            <a:pPr marL="0" indent="0">
+              <a:buNone/>
+            </a:pPr>
+            <a:r>
+              <a:rPr lang="nl-NL" sz="1800" dirty="0">
+                <a:latin typeface="Courier New" panose="02070309020205020404" pitchFamily="49" charset="0"/>
+                <a:cs typeface="Courier New" panose="02070309020205020404" pitchFamily="49" charset="0"/>
+              </a:rPr>
+              <a:t>http://127.0.0.1:8000/add?description=&lt;beschrijving hier&gt;</a:t>
+            </a:r>
+          </a:p>
+        </p:txBody>
+      </p:sp>
+    </p:spTree>
+    <p:extLst>
+      <p:ext uri="{BB962C8B-B14F-4D97-AF65-F5344CB8AC3E}">
+        <p14:creationId xmlns:p14="http://schemas.microsoft.com/office/powerpoint/2010/main" val="2547045887"/>
+      </p:ext>
+    </p:extLst>
+  </p:cSld>
+  <p:clrMapOvr>
+    <a:masterClrMapping/>
+  </p:clrMapOvr>
+</p:sld>
+</file>
+
+<file path=ppt/slides/slide24.xml><?xml version="1.0" encoding="utf-8"?>
+<p:sld xmlns:a="http://schemas.openxmlformats.org/drawingml/2006/main" xmlns:r="http://schemas.openxmlformats.org/officeDocument/2006/relationships" xmlns:p="http://schemas.openxmlformats.org/presentationml/2006/main">
+  <p:cSld>
+    <p:spTree>
+      <p:nvGrpSpPr>
+        <p:cNvPr id="1" name="">
+          <a:extLst>
+            <a:ext uri="{FF2B5EF4-FFF2-40B4-BE49-F238E27FC236}">
+              <a16:creationId xmlns:a16="http://schemas.microsoft.com/office/drawing/2014/main" id="{EBEF6D58-3712-9EFD-1828-488751D1BEDA}"/>
+            </a:ext>
+          </a:extLst>
+        </p:cNvPr>
+        <p:cNvGrpSpPr/>
+        <p:nvPr/>
+      </p:nvGrpSpPr>
+      <p:grpSpPr>
+        <a:xfrm>
+          <a:off x="0" y="0"/>
+          <a:ext cx="0" cy="0"/>
+          <a:chOff x="0" y="0"/>
+          <a:chExt cx="0" cy="0"/>
+        </a:xfrm>
+      </p:grpSpPr>
+      <p:sp>
+        <p:nvSpPr>
+          <p:cNvPr id="2" name="Title 1">
+            <a:extLst>
+              <a:ext uri="{FF2B5EF4-FFF2-40B4-BE49-F238E27FC236}">
+                <a16:creationId xmlns:a16="http://schemas.microsoft.com/office/drawing/2014/main" id="{BCF2DA2B-05C7-97B5-C30C-BAFE63E5E878}"/>
+              </a:ext>
+            </a:extLst>
+          </p:cNvPr>
+          <p:cNvSpPr>
+            <a:spLocks noGrp="1"/>
+          </p:cNvSpPr>
+          <p:nvPr>
+            <p:ph type="title"/>
+          </p:nvPr>
+        </p:nvSpPr>
+        <p:spPr>
+          <a:xfrm>
+            <a:off x="838200" y="365126"/>
+            <a:ext cx="10515600" cy="718608"/>
+          </a:xfrm>
+        </p:spPr>
+        <p:txBody>
+          <a:bodyPr>
+            <a:normAutofit/>
+          </a:bodyPr>
+          <a:lstStyle/>
+          <a:p>
+            <a:r>
+              <a:rPr lang="nl-NL" sz="3600" dirty="0"/>
+              <a:t>De overige </a:t>
+            </a:r>
+            <a:r>
+              <a:rPr lang="nl-NL" sz="3600" dirty="0" err="1"/>
+              <a:t>endpoints</a:t>
+            </a:r>
+            <a:endParaRPr lang="nl-NL" sz="3600" noProof="0" dirty="0"/>
+          </a:p>
+        </p:txBody>
+      </p:sp>
+      <p:sp>
+        <p:nvSpPr>
+          <p:cNvPr id="3" name="Content Placeholder 2">
+            <a:extLst>
+              <a:ext uri="{FF2B5EF4-FFF2-40B4-BE49-F238E27FC236}">
+                <a16:creationId xmlns:a16="http://schemas.microsoft.com/office/drawing/2014/main" id="{24172C65-11DE-9ABE-AADF-90650C5B99D2}"/>
+              </a:ext>
+            </a:extLst>
+          </p:cNvPr>
+          <p:cNvSpPr>
+            <a:spLocks noGrp="1"/>
+          </p:cNvSpPr>
+          <p:nvPr>
+            <p:ph idx="1"/>
+          </p:nvPr>
+        </p:nvSpPr>
+        <p:spPr>
+          <a:xfrm>
+            <a:off x="838200" y="1456267"/>
+            <a:ext cx="5257800" cy="4720696"/>
+          </a:xfrm>
+        </p:spPr>
+        <p:txBody>
+          <a:bodyPr>
+            <a:noAutofit/>
+          </a:bodyPr>
+          <a:lstStyle/>
+          <a:p>
+            <a:pPr marL="0" indent="0">
+              <a:spcAft>
+                <a:spcPts val="600"/>
+              </a:spcAft>
+              <a:buNone/>
+            </a:pPr>
+            <a:r>
+              <a:rPr lang="nl-NL" sz="1600" dirty="0">
+                <a:latin typeface="Courier New" panose="02070309020205020404" pitchFamily="49" charset="0"/>
+                <a:cs typeface="Courier New" panose="02070309020205020404" pitchFamily="49" charset="0"/>
+              </a:rPr>
+              <a:t>/</a:t>
+            </a:r>
+          </a:p>
+          <a:p>
+            <a:pPr marL="0" indent="0">
+              <a:spcAft>
+                <a:spcPts val="600"/>
+              </a:spcAft>
+              <a:buNone/>
+            </a:pPr>
+            <a:r>
+              <a:rPr lang="nl-NL" sz="1600" dirty="0"/>
+              <a:t>Leest alle JSON files uit de </a:t>
+            </a:r>
+            <a:r>
+              <a:rPr lang="nl-NL" sz="1600" dirty="0" err="1"/>
+              <a:t>To</a:t>
+            </a:r>
+            <a:r>
+              <a:rPr lang="nl-NL" sz="1600" dirty="0"/>
+              <a:t> Do folder.</a:t>
+            </a:r>
+          </a:p>
+          <a:p>
+            <a:pPr marL="0" indent="0">
+              <a:spcAft>
+                <a:spcPts val="600"/>
+              </a:spcAft>
+              <a:buNone/>
+            </a:pPr>
+            <a:r>
+              <a:rPr lang="nl-NL" sz="1600" dirty="0"/>
+              <a:t>Geeft deze als lijst van </a:t>
+            </a:r>
+            <a:r>
+              <a:rPr lang="nl-NL" sz="1600" dirty="0" err="1"/>
+              <a:t>ToDoItems</a:t>
+            </a:r>
+            <a:r>
+              <a:rPr lang="nl-NL" sz="1600" dirty="0"/>
+              <a:t> terug.</a:t>
+            </a:r>
+          </a:p>
+          <a:p>
+            <a:pPr marL="0" indent="0">
+              <a:spcAft>
+                <a:spcPts val="600"/>
+              </a:spcAft>
+              <a:buNone/>
+            </a:pPr>
+            <a:endParaRPr lang="nl-NL" sz="1600" dirty="0"/>
+          </a:p>
+          <a:p>
+            <a:pPr marL="0" indent="0">
+              <a:spcAft>
+                <a:spcPts val="600"/>
+              </a:spcAft>
+              <a:buNone/>
+            </a:pPr>
+            <a:r>
+              <a:rPr lang="nl-NL" sz="1600" dirty="0">
+                <a:latin typeface="Courier New" panose="02070309020205020404" pitchFamily="49" charset="0"/>
+                <a:cs typeface="Courier New" panose="02070309020205020404" pitchFamily="49" charset="0"/>
+              </a:rPr>
+              <a:t>/</a:t>
+            </a:r>
+            <a:r>
+              <a:rPr lang="nl-NL" sz="1600" dirty="0" err="1">
+                <a:latin typeface="Courier New" panose="02070309020205020404" pitchFamily="49" charset="0"/>
+                <a:cs typeface="Courier New" panose="02070309020205020404" pitchFamily="49" charset="0"/>
+              </a:rPr>
+              <a:t>update?id</a:t>
+            </a:r>
+            <a:r>
+              <a:rPr lang="nl-NL" sz="1600" dirty="0">
+                <a:latin typeface="Courier New" panose="02070309020205020404" pitchFamily="49" charset="0"/>
+                <a:cs typeface="Courier New" panose="02070309020205020404" pitchFamily="49" charset="0"/>
+              </a:rPr>
+              <a:t>=…&amp;status=…</a:t>
+            </a:r>
+          </a:p>
+          <a:p>
+            <a:pPr marL="0" indent="0">
+              <a:spcAft>
+                <a:spcPts val="600"/>
+              </a:spcAft>
+              <a:buNone/>
+            </a:pPr>
+            <a:r>
+              <a:rPr lang="nl-NL" sz="1600" dirty="0"/>
+              <a:t>Zet status van het </a:t>
+            </a:r>
+            <a:r>
+              <a:rPr lang="nl-NL" sz="1600" dirty="0" err="1"/>
+              <a:t>ToDoItem</a:t>
+            </a:r>
+            <a:r>
+              <a:rPr lang="nl-NL" sz="1600" dirty="0"/>
+              <a:t> op </a:t>
+            </a:r>
+            <a:r>
+              <a:rPr lang="nl-NL" sz="1600" dirty="0">
+                <a:latin typeface="Courier New" panose="02070309020205020404" pitchFamily="49" charset="0"/>
+                <a:cs typeface="Courier New" panose="02070309020205020404" pitchFamily="49" charset="0"/>
+              </a:rPr>
+              <a:t>Active</a:t>
+            </a:r>
+            <a:r>
+              <a:rPr lang="nl-NL" sz="1600" dirty="0"/>
+              <a:t> of </a:t>
+            </a:r>
+            <a:r>
+              <a:rPr lang="nl-NL" sz="1600" dirty="0" err="1">
+                <a:latin typeface="Courier New" panose="02070309020205020404" pitchFamily="49" charset="0"/>
+                <a:cs typeface="Courier New" panose="02070309020205020404" pitchFamily="49" charset="0"/>
+              </a:rPr>
+              <a:t>Done</a:t>
+            </a:r>
+            <a:r>
+              <a:rPr lang="nl-NL" sz="1600" dirty="0"/>
+              <a:t>.</a:t>
+            </a:r>
+          </a:p>
+          <a:p>
+            <a:pPr marL="0" indent="0">
+              <a:spcAft>
+                <a:spcPts val="600"/>
+              </a:spcAft>
+              <a:buNone/>
+            </a:pPr>
+            <a:r>
+              <a:rPr lang="nl-NL" sz="1600" dirty="0"/>
+              <a:t>Overschrijf het JSON-bestand in de </a:t>
+            </a:r>
+            <a:r>
+              <a:rPr lang="nl-NL" sz="1600" dirty="0" err="1"/>
+              <a:t>To</a:t>
+            </a:r>
+            <a:r>
+              <a:rPr lang="nl-NL" sz="1600" dirty="0"/>
+              <a:t> Do folder.</a:t>
+            </a:r>
+          </a:p>
+          <a:p>
+            <a:pPr marL="0" indent="0">
+              <a:spcAft>
+                <a:spcPts val="600"/>
+              </a:spcAft>
+              <a:buNone/>
+            </a:pPr>
+            <a:endParaRPr lang="nl-NL" sz="1600" dirty="0"/>
+          </a:p>
+          <a:p>
+            <a:pPr marL="0" indent="0">
+              <a:spcAft>
+                <a:spcPts val="600"/>
+              </a:spcAft>
+              <a:buNone/>
+            </a:pPr>
+            <a:endParaRPr lang="nl-NL" sz="1600" dirty="0"/>
+          </a:p>
+          <a:p>
+            <a:pPr marL="0" indent="0">
+              <a:spcAft>
+                <a:spcPts val="600"/>
+              </a:spcAft>
+              <a:buNone/>
+            </a:pPr>
+            <a:r>
+              <a:rPr lang="nl-NL" sz="1600" dirty="0">
+                <a:latin typeface="Courier New" panose="02070309020205020404" pitchFamily="49" charset="0"/>
+                <a:cs typeface="Courier New" panose="02070309020205020404" pitchFamily="49" charset="0"/>
+              </a:rPr>
+              <a:t>/</a:t>
+            </a:r>
+            <a:r>
+              <a:rPr lang="nl-NL" sz="1600" dirty="0" err="1">
+                <a:latin typeface="Courier New" panose="02070309020205020404" pitchFamily="49" charset="0"/>
+                <a:cs typeface="Courier New" panose="02070309020205020404" pitchFamily="49" charset="0"/>
+              </a:rPr>
+              <a:t>delete?id</a:t>
+            </a:r>
+            <a:r>
+              <a:rPr lang="nl-NL" sz="1600" dirty="0">
+                <a:latin typeface="Courier New" panose="02070309020205020404" pitchFamily="49" charset="0"/>
+                <a:cs typeface="Courier New" panose="02070309020205020404" pitchFamily="49" charset="0"/>
+              </a:rPr>
+              <a:t>=…</a:t>
+            </a:r>
+            <a:endParaRPr lang="nl-NL" sz="1600" dirty="0"/>
+          </a:p>
+          <a:p>
+            <a:pPr marL="0" indent="0">
+              <a:spcAft>
+                <a:spcPts val="600"/>
+              </a:spcAft>
+              <a:buNone/>
+            </a:pPr>
+            <a:r>
+              <a:rPr lang="nl-NL" sz="1600" dirty="0"/>
+              <a:t>Verwijderd het JSON bestand met het opgegeven </a:t>
+            </a:r>
+            <a:r>
+              <a:rPr lang="nl-NL" sz="1600"/>
+              <a:t>ID.</a:t>
+            </a:r>
+            <a:endParaRPr lang="nl-NL" sz="1600" dirty="0"/>
+          </a:p>
+        </p:txBody>
+      </p:sp>
+      <p:sp>
+        <p:nvSpPr>
+          <p:cNvPr id="4" name="Content Placeholder 2">
+            <a:extLst>
+              <a:ext uri="{FF2B5EF4-FFF2-40B4-BE49-F238E27FC236}">
+                <a16:creationId xmlns:a16="http://schemas.microsoft.com/office/drawing/2014/main" id="{BDBC0DFA-4E08-4F97-A95B-3820EE32F204}"/>
+              </a:ext>
+            </a:extLst>
+          </p:cNvPr>
+          <p:cNvSpPr txBox="1">
+            <a:spLocks/>
+          </p:cNvSpPr>
+          <p:nvPr/>
+        </p:nvSpPr>
+        <p:spPr>
+          <a:xfrm>
+            <a:off x="6750050" y="1456267"/>
+            <a:ext cx="4603750" cy="4720696"/>
+          </a:xfrm>
+          <a:prstGeom prst="rect">
+            <a:avLst/>
+          </a:prstGeom>
+        </p:spPr>
+        <p:txBody>
+          <a:bodyPr vert="horz" lIns="91440" tIns="45720" rIns="91440" bIns="45720" rtlCol="0">
+            <a:normAutofit/>
+          </a:bodyPr>
+          <a:lstStyle>
+            <a:lvl1pPr marL="228600" indent="-228600" algn="l" defTabSz="914400" rtl="0" eaLnBrk="1" latinLnBrk="0" hangingPunct="1">
+              <a:lnSpc>
+                <a:spcPct val="90000"/>
+              </a:lnSpc>
+              <a:spcBef>
+                <a:spcPts val="1000"/>
+              </a:spcBef>
+              <a:buFont typeface="Arial" panose="020B0604020202020204" pitchFamily="34" charset="0"/>
+              <a:buChar char="•"/>
+              <a:defRPr sz="2800" kern="1200">
+                <a:solidFill>
+                  <a:schemeClr val="tx1"/>
+                </a:solidFill>
+                <a:latin typeface="+mn-lt"/>
+                <a:ea typeface="+mn-ea"/>
+                <a:cs typeface="+mn-cs"/>
+              </a:defRPr>
+            </a:lvl1pPr>
+            <a:lvl2pPr marL="685800" indent="-228600" algn="l" defTabSz="914400" rtl="0" eaLnBrk="1" latinLnBrk="0" hangingPunct="1">
+              <a:lnSpc>
+                <a:spcPct val="90000"/>
+              </a:lnSpc>
+              <a:spcBef>
+                <a:spcPts val="500"/>
+              </a:spcBef>
+              <a:buFont typeface="Arial" panose="020B0604020202020204" pitchFamily="34" charset="0"/>
+              <a:buChar char="•"/>
+              <a:defRPr sz="2400" kern="1200">
+                <a:solidFill>
+                  <a:schemeClr val="tx1"/>
+                </a:solidFill>
+                <a:latin typeface="+mn-lt"/>
+                <a:ea typeface="+mn-ea"/>
+                <a:cs typeface="+mn-cs"/>
+              </a:defRPr>
+            </a:lvl2pPr>
+            <a:lvl3pPr marL="1143000" indent="-228600" algn="l" defTabSz="914400" rtl="0" eaLnBrk="1" latinLnBrk="0" hangingPunct="1">
+              <a:lnSpc>
+                <a:spcPct val="90000"/>
+              </a:lnSpc>
+              <a:spcBef>
+                <a:spcPts val="500"/>
+              </a:spcBef>
+              <a:buFont typeface="Arial" panose="020B0604020202020204" pitchFamily="34" charset="0"/>
+              <a:buChar char="•"/>
+              <a:defRPr sz="2000" kern="1200">
+                <a:solidFill>
+                  <a:schemeClr val="tx1"/>
+                </a:solidFill>
+                <a:latin typeface="+mn-lt"/>
+                <a:ea typeface="+mn-ea"/>
+                <a:cs typeface="+mn-cs"/>
+              </a:defRPr>
+            </a:lvl3pPr>
+            <a:lvl4pPr marL="1600200" indent="-228600" algn="l" defTabSz="914400" rtl="0" eaLnBrk="1" latinLnBrk="0" hangingPunct="1">
+              <a:lnSpc>
+                <a:spcPct val="90000"/>
+              </a:lnSpc>
+              <a:spcBef>
+                <a:spcPts val="500"/>
+              </a:spcBef>
+              <a:buFont typeface="Arial" panose="020B0604020202020204" pitchFamily="34" charset="0"/>
+              <a:buChar char="•"/>
+              <a:defRPr sz="1800" kern="1200">
+                <a:solidFill>
+                  <a:schemeClr val="tx1"/>
+                </a:solidFill>
+                <a:latin typeface="+mn-lt"/>
+                <a:ea typeface="+mn-ea"/>
+                <a:cs typeface="+mn-cs"/>
+              </a:defRPr>
+            </a:lvl4pPr>
+            <a:lvl5pPr marL="2057400" indent="-228600" algn="l" defTabSz="914400" rtl="0" eaLnBrk="1" latinLnBrk="0" hangingPunct="1">
+              <a:lnSpc>
+                <a:spcPct val="90000"/>
+              </a:lnSpc>
+              <a:spcBef>
+                <a:spcPts val="500"/>
+              </a:spcBef>
+              <a:buFont typeface="Arial" panose="020B0604020202020204" pitchFamily="34" charset="0"/>
+              <a:buChar char="•"/>
+              <a:defRPr sz="1800" kern="1200">
+                <a:solidFill>
+                  <a:schemeClr val="tx1"/>
+                </a:solidFill>
+                <a:latin typeface="+mn-lt"/>
+                <a:ea typeface="+mn-ea"/>
+                <a:cs typeface="+mn-cs"/>
+              </a:defRPr>
+            </a:lvl5pPr>
+            <a:lvl6pPr marL="2514600" indent="-228600" algn="l" defTabSz="914400" rtl="0" eaLnBrk="1" latinLnBrk="0" hangingPunct="1">
+              <a:lnSpc>
+                <a:spcPct val="90000"/>
+              </a:lnSpc>
+              <a:spcBef>
+                <a:spcPts val="500"/>
+              </a:spcBef>
+              <a:buFont typeface="Arial" panose="020B0604020202020204" pitchFamily="34" charset="0"/>
+              <a:buChar char="•"/>
+              <a:defRPr sz="1800" kern="1200">
+                <a:solidFill>
+                  <a:schemeClr val="tx1"/>
+                </a:solidFill>
+                <a:latin typeface="+mn-lt"/>
+                <a:ea typeface="+mn-ea"/>
+                <a:cs typeface="+mn-cs"/>
+              </a:defRPr>
+            </a:lvl6pPr>
+            <a:lvl7pPr marL="2971800" indent="-228600" algn="l" defTabSz="914400" rtl="0" eaLnBrk="1" latinLnBrk="0" hangingPunct="1">
+              <a:lnSpc>
+                <a:spcPct val="90000"/>
+              </a:lnSpc>
+              <a:spcBef>
+                <a:spcPts val="500"/>
+              </a:spcBef>
+              <a:buFont typeface="Arial" panose="020B0604020202020204" pitchFamily="34" charset="0"/>
+              <a:buChar char="•"/>
+              <a:defRPr sz="1800" kern="1200">
+                <a:solidFill>
+                  <a:schemeClr val="tx1"/>
+                </a:solidFill>
+                <a:latin typeface="+mn-lt"/>
+                <a:ea typeface="+mn-ea"/>
+                <a:cs typeface="+mn-cs"/>
+              </a:defRPr>
+            </a:lvl7pPr>
+            <a:lvl8pPr marL="3429000" indent="-228600" algn="l" defTabSz="914400" rtl="0" eaLnBrk="1" latinLnBrk="0" hangingPunct="1">
+              <a:lnSpc>
+                <a:spcPct val="90000"/>
+              </a:lnSpc>
+              <a:spcBef>
+                <a:spcPts val="500"/>
+              </a:spcBef>
+              <a:buFont typeface="Arial" panose="020B0604020202020204" pitchFamily="34" charset="0"/>
+              <a:buChar char="•"/>
+              <a:defRPr sz="1800" kern="1200">
+                <a:solidFill>
+                  <a:schemeClr val="tx1"/>
+                </a:solidFill>
+                <a:latin typeface="+mn-lt"/>
+                <a:ea typeface="+mn-ea"/>
+                <a:cs typeface="+mn-cs"/>
+              </a:defRPr>
+            </a:lvl8pPr>
+            <a:lvl9pPr marL="3886200" indent="-228600" algn="l" defTabSz="914400" rtl="0" eaLnBrk="1" latinLnBrk="0" hangingPunct="1">
+              <a:lnSpc>
+                <a:spcPct val="90000"/>
+              </a:lnSpc>
+              <a:spcBef>
+                <a:spcPts val="500"/>
+              </a:spcBef>
+              <a:buFont typeface="Arial" panose="020B0604020202020204" pitchFamily="34" charset="0"/>
+              <a:buChar char="•"/>
+              <a:defRPr sz="1800" kern="1200">
+                <a:solidFill>
+                  <a:schemeClr val="tx1"/>
+                </a:solidFill>
+                <a:latin typeface="+mn-lt"/>
+                <a:ea typeface="+mn-ea"/>
+                <a:cs typeface="+mn-cs"/>
+              </a:defRPr>
+            </a:lvl9pPr>
+          </a:lstStyle>
+          <a:p>
+            <a:pPr marL="0" indent="0">
+              <a:lnSpc>
+                <a:spcPct val="100000"/>
+              </a:lnSpc>
+              <a:spcBef>
+                <a:spcPts val="0"/>
+              </a:spcBef>
+              <a:spcAft>
+                <a:spcPts val="600"/>
+              </a:spcAft>
+              <a:buNone/>
+            </a:pPr>
+            <a:endParaRPr lang="nl-NL" sz="1400" dirty="0">
+              <a:latin typeface="Courier New" panose="02070309020205020404" pitchFamily="49" charset="0"/>
+              <a:cs typeface="Courier New" panose="02070309020205020404" pitchFamily="49" charset="0"/>
+            </a:endParaRPr>
+          </a:p>
+          <a:p>
+            <a:pPr marL="0" indent="0">
+              <a:lnSpc>
+                <a:spcPct val="100000"/>
+              </a:lnSpc>
+              <a:spcBef>
+                <a:spcPts val="0"/>
+              </a:spcBef>
+              <a:spcAft>
+                <a:spcPts val="600"/>
+              </a:spcAft>
+              <a:buNone/>
+            </a:pPr>
+            <a:endParaRPr lang="nl-NL" sz="1400" dirty="0">
+              <a:latin typeface="Courier New" panose="02070309020205020404" pitchFamily="49" charset="0"/>
+              <a:cs typeface="Courier New" panose="02070309020205020404" pitchFamily="49" charset="0"/>
+            </a:endParaRPr>
+          </a:p>
+          <a:p>
+            <a:pPr marL="0" indent="0">
+              <a:lnSpc>
+                <a:spcPct val="100000"/>
+              </a:lnSpc>
+              <a:spcBef>
+                <a:spcPts val="0"/>
+              </a:spcBef>
+              <a:spcAft>
+                <a:spcPts val="600"/>
+              </a:spcAft>
+              <a:buNone/>
+            </a:pPr>
+            <a:r>
+              <a:rPr lang="nl-NL" sz="1400" dirty="0" err="1">
+                <a:latin typeface="Courier New" panose="02070309020205020404" pitchFamily="49" charset="0"/>
+                <a:cs typeface="Courier New" panose="02070309020205020404" pitchFamily="49" charset="0"/>
+              </a:rPr>
+              <a:t>Path</a:t>
+            </a:r>
+            <a:r>
+              <a:rPr lang="nl-NL" sz="1400" dirty="0">
+                <a:latin typeface="Courier New" panose="02070309020205020404" pitchFamily="49" charset="0"/>
+                <a:cs typeface="Courier New" panose="02070309020205020404" pitchFamily="49" charset="0"/>
+              </a:rPr>
+              <a:t>("</a:t>
+            </a:r>
+            <a:r>
+              <a:rPr lang="nl-NL" sz="1400" dirty="0" err="1">
+                <a:latin typeface="Courier New" panose="02070309020205020404" pitchFamily="49" charset="0"/>
+                <a:cs typeface="Courier New" panose="02070309020205020404" pitchFamily="49" charset="0"/>
+              </a:rPr>
+              <a:t>todo_folder</a:t>
+            </a:r>
+            <a:r>
+              <a:rPr lang="nl-NL" sz="1400" dirty="0">
+                <a:latin typeface="Courier New" panose="02070309020205020404" pitchFamily="49" charset="0"/>
+                <a:cs typeface="Courier New" panose="02070309020205020404" pitchFamily="49" charset="0"/>
+              </a:rPr>
+              <a:t>").</a:t>
+            </a:r>
+            <a:r>
+              <a:rPr lang="nl-NL" sz="1400" dirty="0" err="1">
+                <a:latin typeface="Courier New" panose="02070309020205020404" pitchFamily="49" charset="0"/>
+                <a:cs typeface="Courier New" panose="02070309020205020404" pitchFamily="49" charset="0"/>
+              </a:rPr>
+              <a:t>glob</a:t>
+            </a:r>
+            <a:r>
+              <a:rPr lang="nl-NL" sz="1400" dirty="0">
+                <a:latin typeface="Courier New" panose="02070309020205020404" pitchFamily="49" charset="0"/>
+                <a:cs typeface="Courier New" panose="02070309020205020404" pitchFamily="49" charset="0"/>
+              </a:rPr>
+              <a:t>("*.</a:t>
+            </a:r>
+            <a:r>
+              <a:rPr lang="nl-NL" sz="1400" dirty="0" err="1">
+                <a:latin typeface="Courier New" panose="02070309020205020404" pitchFamily="49" charset="0"/>
+                <a:cs typeface="Courier New" panose="02070309020205020404" pitchFamily="49" charset="0"/>
+              </a:rPr>
+              <a:t>json</a:t>
+            </a:r>
+            <a:r>
+              <a:rPr lang="nl-NL" sz="1400" dirty="0">
+                <a:latin typeface="Courier New" panose="02070309020205020404" pitchFamily="49" charset="0"/>
+                <a:cs typeface="Courier New" panose="02070309020205020404" pitchFamily="49" charset="0"/>
+              </a:rPr>
+              <a:t>")</a:t>
+            </a:r>
+          </a:p>
+          <a:p>
+            <a:pPr marL="0" indent="0">
+              <a:lnSpc>
+                <a:spcPct val="100000"/>
+              </a:lnSpc>
+              <a:spcBef>
+                <a:spcPts val="0"/>
+              </a:spcBef>
+              <a:spcAft>
+                <a:spcPts val="600"/>
+              </a:spcAft>
+              <a:buNone/>
+            </a:pPr>
+            <a:endParaRPr lang="nl-NL" sz="1400" dirty="0">
+              <a:latin typeface="Courier New" panose="02070309020205020404" pitchFamily="49" charset="0"/>
+              <a:cs typeface="Courier New" panose="02070309020205020404" pitchFamily="49" charset="0"/>
+            </a:endParaRPr>
+          </a:p>
+          <a:p>
+            <a:pPr marL="0" indent="0">
+              <a:lnSpc>
+                <a:spcPct val="100000"/>
+              </a:lnSpc>
+              <a:spcBef>
+                <a:spcPts val="0"/>
+              </a:spcBef>
+              <a:spcAft>
+                <a:spcPts val="600"/>
+              </a:spcAft>
+              <a:buNone/>
+            </a:pPr>
+            <a:endParaRPr lang="nl-NL" sz="1400" dirty="0">
+              <a:latin typeface="Courier New" panose="02070309020205020404" pitchFamily="49" charset="0"/>
+              <a:cs typeface="Courier New" panose="02070309020205020404" pitchFamily="49" charset="0"/>
+            </a:endParaRPr>
+          </a:p>
+          <a:p>
+            <a:pPr marL="0" indent="0">
+              <a:lnSpc>
+                <a:spcPct val="100000"/>
+              </a:lnSpc>
+              <a:spcBef>
+                <a:spcPts val="0"/>
+              </a:spcBef>
+              <a:spcAft>
+                <a:spcPts val="600"/>
+              </a:spcAft>
+              <a:buNone/>
+            </a:pPr>
+            <a:endParaRPr lang="nl-NL" sz="1400" dirty="0">
+              <a:latin typeface="Courier New" panose="02070309020205020404" pitchFamily="49" charset="0"/>
+              <a:cs typeface="Courier New" panose="02070309020205020404" pitchFamily="49" charset="0"/>
+            </a:endParaRPr>
+          </a:p>
+          <a:p>
+            <a:pPr marL="0" indent="0">
+              <a:lnSpc>
+                <a:spcPct val="100000"/>
+              </a:lnSpc>
+              <a:spcBef>
+                <a:spcPts val="0"/>
+              </a:spcBef>
+              <a:spcAft>
+                <a:spcPts val="600"/>
+              </a:spcAft>
+              <a:buNone/>
+            </a:pPr>
+            <a:endParaRPr lang="nl-NL" sz="1400" dirty="0">
+              <a:latin typeface="Courier New" panose="02070309020205020404" pitchFamily="49" charset="0"/>
+              <a:cs typeface="Courier New" panose="02070309020205020404" pitchFamily="49" charset="0"/>
+            </a:endParaRPr>
+          </a:p>
+          <a:p>
+            <a:pPr marL="0" indent="0">
+              <a:lnSpc>
+                <a:spcPct val="100000"/>
+              </a:lnSpc>
+              <a:spcBef>
+                <a:spcPts val="0"/>
+              </a:spcBef>
+              <a:spcAft>
+                <a:spcPts val="600"/>
+              </a:spcAft>
+              <a:buNone/>
+            </a:pPr>
+            <a:r>
+              <a:rPr lang="nl-NL" sz="1400" dirty="0">
+                <a:latin typeface="Courier New" panose="02070309020205020404" pitchFamily="49" charset="0"/>
+                <a:cs typeface="Courier New" panose="02070309020205020404" pitchFamily="49" charset="0"/>
+              </a:rPr>
+              <a:t>open(…, </a:t>
+            </a:r>
+            <a:r>
+              <a:rPr lang="nl-NL" sz="1400" b="1" dirty="0">
+                <a:latin typeface="Courier New" panose="02070309020205020404" pitchFamily="49" charset="0"/>
+                <a:cs typeface="Courier New" panose="02070309020205020404" pitchFamily="49" charset="0"/>
+              </a:rPr>
+              <a:t>"w"</a:t>
+            </a:r>
+            <a:r>
+              <a:rPr lang="nl-NL" sz="1400" dirty="0">
+                <a:latin typeface="Courier New" panose="02070309020205020404" pitchFamily="49" charset="0"/>
+                <a:cs typeface="Courier New" panose="02070309020205020404" pitchFamily="49" charset="0"/>
+              </a:rPr>
+              <a:t>, </a:t>
+            </a:r>
+            <a:r>
+              <a:rPr lang="nl-NL" sz="1400" dirty="0" err="1">
+                <a:latin typeface="Courier New" panose="02070309020205020404" pitchFamily="49" charset="0"/>
+                <a:cs typeface="Courier New" panose="02070309020205020404" pitchFamily="49" charset="0"/>
+              </a:rPr>
+              <a:t>encoding</a:t>
+            </a:r>
+            <a:r>
+              <a:rPr lang="nl-NL" sz="1400" dirty="0">
+                <a:latin typeface="Courier New" panose="02070309020205020404" pitchFamily="49" charset="0"/>
+                <a:cs typeface="Courier New" panose="02070309020205020404" pitchFamily="49" charset="0"/>
+              </a:rPr>
+              <a:t>="utf8")</a:t>
+            </a:r>
+          </a:p>
+          <a:p>
+            <a:pPr marL="0" indent="0">
+              <a:lnSpc>
+                <a:spcPct val="100000"/>
+              </a:lnSpc>
+              <a:spcBef>
+                <a:spcPts val="0"/>
+              </a:spcBef>
+              <a:spcAft>
+                <a:spcPts val="600"/>
+              </a:spcAft>
+              <a:buNone/>
+            </a:pPr>
+            <a:endParaRPr lang="nl-NL" sz="1400" dirty="0">
+              <a:latin typeface="Courier New" panose="02070309020205020404" pitchFamily="49" charset="0"/>
+              <a:cs typeface="Courier New" panose="02070309020205020404" pitchFamily="49" charset="0"/>
+            </a:endParaRPr>
+          </a:p>
+          <a:p>
+            <a:pPr marL="0" indent="0">
+              <a:lnSpc>
+                <a:spcPct val="100000"/>
+              </a:lnSpc>
+              <a:spcBef>
+                <a:spcPts val="0"/>
+              </a:spcBef>
+              <a:spcAft>
+                <a:spcPts val="600"/>
+              </a:spcAft>
+              <a:buNone/>
+            </a:pPr>
+            <a:endParaRPr lang="nl-NL" sz="1400" dirty="0">
+              <a:latin typeface="Courier New" panose="02070309020205020404" pitchFamily="49" charset="0"/>
+              <a:cs typeface="Courier New" panose="02070309020205020404" pitchFamily="49" charset="0"/>
+            </a:endParaRPr>
+          </a:p>
+          <a:p>
+            <a:pPr marL="0" indent="0">
+              <a:lnSpc>
+                <a:spcPct val="100000"/>
+              </a:lnSpc>
+              <a:spcBef>
+                <a:spcPts val="0"/>
+              </a:spcBef>
+              <a:spcAft>
+                <a:spcPts val="600"/>
+              </a:spcAft>
+              <a:buNone/>
+            </a:pPr>
+            <a:endParaRPr lang="en-US" sz="1400" dirty="0">
+              <a:latin typeface="Courier New" panose="02070309020205020404" pitchFamily="49" charset="0"/>
+              <a:cs typeface="Courier New" panose="02070309020205020404" pitchFamily="49" charset="0"/>
+            </a:endParaRPr>
+          </a:p>
+          <a:p>
+            <a:pPr marL="0" indent="0">
+              <a:lnSpc>
+                <a:spcPct val="100000"/>
+              </a:lnSpc>
+              <a:spcBef>
+                <a:spcPts val="0"/>
+              </a:spcBef>
+              <a:spcAft>
+                <a:spcPts val="600"/>
+              </a:spcAft>
+              <a:buNone/>
+            </a:pPr>
+            <a:endParaRPr lang="en-US" sz="1400" dirty="0">
+              <a:latin typeface="Courier New" panose="02070309020205020404" pitchFamily="49" charset="0"/>
+              <a:cs typeface="Courier New" panose="02070309020205020404" pitchFamily="49" charset="0"/>
+            </a:endParaRPr>
+          </a:p>
+          <a:p>
+            <a:pPr marL="0" indent="0">
+              <a:lnSpc>
+                <a:spcPct val="100000"/>
+              </a:lnSpc>
+              <a:spcBef>
+                <a:spcPts val="0"/>
+              </a:spcBef>
+              <a:spcAft>
+                <a:spcPts val="600"/>
+              </a:spcAft>
+              <a:buNone/>
+            </a:pPr>
+            <a:endParaRPr lang="en-US" sz="1400" dirty="0">
+              <a:latin typeface="Courier New" panose="02070309020205020404" pitchFamily="49" charset="0"/>
+              <a:cs typeface="Courier New" panose="02070309020205020404" pitchFamily="49" charset="0"/>
+            </a:endParaRPr>
+          </a:p>
+          <a:p>
+            <a:pPr marL="0" indent="0">
+              <a:lnSpc>
+                <a:spcPct val="100000"/>
+              </a:lnSpc>
+              <a:spcBef>
+                <a:spcPts val="0"/>
+              </a:spcBef>
+              <a:spcAft>
+                <a:spcPts val="600"/>
+              </a:spcAft>
+              <a:buNone/>
+            </a:pPr>
+            <a:endParaRPr lang="en-US" sz="1400" dirty="0">
+              <a:latin typeface="Courier New" panose="02070309020205020404" pitchFamily="49" charset="0"/>
+              <a:cs typeface="Courier New" panose="02070309020205020404" pitchFamily="49" charset="0"/>
+            </a:endParaRPr>
+          </a:p>
+          <a:p>
+            <a:pPr marL="0" indent="0">
+              <a:lnSpc>
+                <a:spcPct val="100000"/>
+              </a:lnSpc>
+              <a:spcBef>
+                <a:spcPts val="0"/>
+              </a:spcBef>
+              <a:spcAft>
+                <a:spcPts val="600"/>
+              </a:spcAft>
+              <a:buNone/>
+            </a:pPr>
+            <a:r>
+              <a:rPr lang="en-US" sz="1400" dirty="0" err="1">
+                <a:latin typeface="Courier New" panose="02070309020205020404" pitchFamily="49" charset="0"/>
+                <a:cs typeface="Courier New" panose="02070309020205020404" pitchFamily="49" charset="0"/>
+              </a:rPr>
+              <a:t>os.remove</a:t>
+            </a:r>
+            <a:r>
+              <a:rPr lang="en-US" sz="1400" dirty="0">
+                <a:latin typeface="Courier New" panose="02070309020205020404" pitchFamily="49" charset="0"/>
+                <a:cs typeface="Courier New" panose="02070309020205020404" pitchFamily="49" charset="0"/>
+              </a:rPr>
+              <a:t>("</a:t>
+            </a:r>
+            <a:r>
+              <a:rPr lang="en-US" sz="1400" dirty="0" err="1">
+                <a:latin typeface="Courier New" panose="02070309020205020404" pitchFamily="49" charset="0"/>
+                <a:cs typeface="Courier New" panose="02070309020205020404" pitchFamily="49" charset="0"/>
+              </a:rPr>
+              <a:t>filename.json</a:t>
+            </a:r>
+            <a:r>
+              <a:rPr lang="en-US" sz="1400" dirty="0">
+                <a:latin typeface="Courier New" panose="02070309020205020404" pitchFamily="49" charset="0"/>
+                <a:cs typeface="Courier New" panose="02070309020205020404" pitchFamily="49" charset="0"/>
+              </a:rPr>
+              <a:t>")</a:t>
+            </a:r>
+          </a:p>
+        </p:txBody>
+      </p:sp>
+      <p:cxnSp>
+        <p:nvCxnSpPr>
+          <p:cNvPr id="6" name="Straight Connector 5">
+            <a:extLst>
+              <a:ext uri="{FF2B5EF4-FFF2-40B4-BE49-F238E27FC236}">
+                <a16:creationId xmlns:a16="http://schemas.microsoft.com/office/drawing/2014/main" id="{02B5AC2C-6398-7F94-A224-CD0F301DA6D0}"/>
+              </a:ext>
+            </a:extLst>
+          </p:cNvPr>
+          <p:cNvCxnSpPr/>
+          <p:nvPr/>
+        </p:nvCxnSpPr>
+        <p:spPr>
+          <a:xfrm>
+            <a:off x="6337300" y="1397000"/>
+            <a:ext cx="0" cy="4838700"/>
+          </a:xfrm>
+          <a:prstGeom prst="line">
+            <a:avLst/>
+          </a:prstGeom>
+        </p:spPr>
+        <p:style>
+          <a:lnRef idx="3">
+            <a:schemeClr val="dk1"/>
+          </a:lnRef>
+          <a:fillRef idx="0">
+            <a:schemeClr val="dk1"/>
+          </a:fillRef>
+          <a:effectRef idx="2">
+            <a:schemeClr val="dk1"/>
+          </a:effectRef>
+          <a:fontRef idx="minor">
+            <a:schemeClr val="tx1"/>
+          </a:fontRef>
+        </p:style>
+      </p:cxnSp>
+      <p:sp>
+        <p:nvSpPr>
+          <p:cNvPr id="5" name="TextBox 4">
+            <a:extLst>
+              <a:ext uri="{FF2B5EF4-FFF2-40B4-BE49-F238E27FC236}">
+                <a16:creationId xmlns:a16="http://schemas.microsoft.com/office/drawing/2014/main" id="{4DC51970-2AD7-A300-61EE-B6204FB4EB80}"/>
+              </a:ext>
+            </a:extLst>
+          </p:cNvPr>
+          <p:cNvSpPr txBox="1"/>
+          <p:nvPr/>
+        </p:nvSpPr>
+        <p:spPr>
+          <a:xfrm>
+            <a:off x="9619967" y="6471982"/>
+            <a:ext cx="2499246" cy="307777"/>
+          </a:xfrm>
+          <a:prstGeom prst="rect">
+            <a:avLst/>
+          </a:prstGeom>
+          <a:noFill/>
+        </p:spPr>
+        <p:txBody>
+          <a:bodyPr wrap="square">
+            <a:spAutoFit/>
+          </a:bodyPr>
+          <a:lstStyle/>
+          <a:p>
+            <a:pPr algn="r"/>
+            <a:r>
+              <a:rPr lang="en-US" sz="1400" dirty="0"/>
+              <a:t>D: params </a:t>
+            </a:r>
+            <a:r>
+              <a:rPr lang="en-US" sz="1400" dirty="0" err="1"/>
+              <a:t>api</a:t>
+            </a:r>
+            <a:r>
+              <a:rPr lang="en-US" sz="1400" dirty="0"/>
+              <a:t>.</a:t>
+            </a:r>
+          </a:p>
+        </p:txBody>
+      </p:sp>
+    </p:spTree>
+    <p:extLst>
+      <p:ext uri="{BB962C8B-B14F-4D97-AF65-F5344CB8AC3E}">
+        <p14:creationId xmlns:p14="http://schemas.microsoft.com/office/powerpoint/2010/main" val="2439698916"/>
       </p:ext>
     </p:extLst>
   </p:cSld>

</xml_diff>